<commit_message>
M23/M24: Quiz-JSONs (Kirkpatrick L2) ergaenzt + M24-Deck aus YAML (6.5)
Co-Authored-By: Claude Opus 4.8 <noreply@anthropic.com>
</commit_message>
<xml_diff>
--- a/protected-downloads/praesentation/M24.pptx
+++ b/protected-downloads/praesentation/M24.pptx
@@ -6684,13 +6684,13 @@
               </a:spcAft>
             </a:pPr>
             <a:r>
-              <a:rPr sz="1200">
+              <a:rPr sz="1300">
                 <a:solidFill>
                   <a:srgbClr val="3D5466"/>
                 </a:solidFill>
                 <a:latin typeface="Arial"/>
               </a:rPr>
-              <a:t>Bevor ein mittelständisches Ergebnis bewertet werden kann, muss es normalisiert werden. Drei Korrekturen sind fast immer nötig:</a:t>
+              <a:t>▸  Bevor ein mittelständisches Ergebnis bewertet werden kann, muss es normalisiert werden. Drei Korrekturen sind fast immer nötig:</a:t>
             </a:r>
           </a:p>
           <a:p>

</xml_diff>